<commit_message>
[T03 2026-09-02] feat: model customer process in BPMN 01-09 instead of black box (E-16)
- bpmngen: partner pools with their own non-executable process, message
  flows between concrete elements, optional snap=False routing
- diagrams: customer flows for P01-P09 (e.g. P01 take photo/video/audio,
  send request, answer follow-up questions, accept appointment, end);
  supplier stays an empty pool (black box)
- layout fixes found by the new tools/check_layout.py (P04, P08, P09)
- mkstats counts the Werkstatt process only, customer activities
  separately (kunde_activities); 121 activities, 24 customer activities
- docs, slides, crops, ZIP regenerated; E-16 added, E-06 adjusted

Co-Authored-By: Claude Opus 5.5 <noreply@anthropic.com>
Claude-Session: https://claude.ai/code/session_01H2bGsFaySUqsEjJ1PXuxUw
</commit_message>
<xml_diff>
--- a/praesi/Abschlusspraesentation.pptx
+++ b/praesi/Abschlusspraesentation.pptx
@@ -2116,7 +2116,7 @@
             <a:r>
               <a:rPr lang="en-US" dirty="0"/>
               <a:t>Vortragende(r): Maxi
-Regeln aus der Vorlesung: Pool = Unternehmen, Lane = Rolle, keine Lane für Software. Automatisierung zeigt der Aktivitätstyp.</a:t>
+Regeln aus der Vorlesung: Pool = Unternehmen, Lane = Rolle, keine Lane für Software. Automatisierung zeigt der Aktivitätstyp. Der Kunde hat einen eigenen, nicht ausführbaren Ablauf (z. B. Foto aufnehmen, Anfrage senden, KVA freigeben), der Lieferant bleibt Black Box.</a:t>
             </a:r>
             <a:endParaRPr lang="en-US" dirty="0"/>
           </a:p>
@@ -3076,7 +3076,7 @@
       </p:sp>
       <p:pic>
         <p:nvPicPr>
-          <p:cNvPr id="6" name="Image 0" descr="/tmp/repo/tools/pres/crop-04-mitte.png">    </p:cNvPr>
+          <p:cNvPr id="6" name="Image 0" descr="/tmp/claude-0/-home-claude/3b43456e-f09e-5adb-b78c-d3b2ad830e83/scratchpad/build/pres/crop-04-mitte.png">    </p:cNvPr>
           <p:cNvPicPr>
             <a:picLocks noChangeAspect="1"/>
           </p:cNvPicPr>
@@ -3090,8 +3090,8 @@
         </p:blipFill>
         <p:spPr>
           <a:xfrm>
-            <a:off x="2215127" y="960120"/>
-            <a:ext cx="4713746" cy="2423160"/>
+            <a:off x="1808596" y="960120"/>
+            <a:ext cx="5526808" cy="2423160"/>
           </a:xfrm>
           <a:prstGeom prst="rect">
             <a:avLst/>
@@ -3131,7 +3131,7 @@
                 <a:ea typeface="Calibri" pitchFamily="34" charset="-122"/>
                 <a:cs typeface="Calibri" pitchFamily="34" charset="-120"/>
               </a:rPr>
-              <a:t>Mittlerer Teil: Senden, ereignisbasiertes Gateway mit Freigabe, Ablehnung und Timer, Erinnerungsschleife</a:t>
+              <a:t>Ausschnitt Pool Kunde und Lane Service / Annahme: Kunde prüft und entscheidet, ereignisbasiertes Gateway mit Freigabe, Ablehnung und Timer, Erinnerungsschleife</a:t>
             </a:r>
             <a:endParaRPr lang="en-US" sz="900" dirty="0"/>
           </a:p>
@@ -4540,7 +4540,7 @@
       </p:sp>
       <p:pic>
         <p:nvPicPr>
-          <p:cNvPr id="6" name="Image 0" descr="/tmp/repo/tools/uml2/usecase.png">    </p:cNvPr>
+          <p:cNvPr id="6" name="Image 0" descr="/tmp/claude-0/-home-claude/3b43456e-f09e-5adb-b78c-d3b2ad830e83/scratchpad/build/uml2/usecase.png">    </p:cNvPr>
           <p:cNvPicPr>
             <a:picLocks noChangeAspect="1"/>
           </p:cNvPicPr>
@@ -4840,7 +4840,7 @@
       </p:sp>
       <p:pic>
         <p:nvPicPr>
-          <p:cNvPr id="6" name="Image 0" descr="/tmp/repo/tools/uml2/klassen-fokus-1-sofortdiagnose.png">    </p:cNvPr>
+          <p:cNvPr id="6" name="Image 0" descr="/tmp/claude-0/-home-claude/3b43456e-f09e-5adb-b78c-d3b2ad830e83/scratchpad/build/uml2/klassen-fokus-1-sofortdiagnose.png">    </p:cNvPr>
           <p:cNvPicPr>
             <a:picLocks noChangeAspect="1"/>
           </p:cNvPicPr>
@@ -5179,7 +5179,7 @@
       </p:sp>
       <p:pic>
         <p:nvPicPr>
-          <p:cNvPr id="6" name="Image 0" descr="/tmp/repo/tools/uml2/sequenz-01-sofortdiagnose.png">    </p:cNvPr>
+          <p:cNvPr id="6" name="Image 0" descr="/tmp/claude-0/-home-claude/3b43456e-f09e-5adb-b78c-d3b2ad830e83/scratchpad/build/uml2/sequenz-01-sofortdiagnose.png">    </p:cNvPr>
           <p:cNvPicPr>
             <a:picLocks noChangeAspect="1"/>
           </p:cNvPicPr>
@@ -5479,7 +5479,7 @@
       </p:sp>
       <p:pic>
         <p:nvPicPr>
-          <p:cNvPr id="6" name="Image 0" descr="/tmp/repo/tools/uml2/sequenz-03-reservierung.png">    </p:cNvPr>
+          <p:cNvPr id="6" name="Image 0" descr="/tmp/claude-0/-home-claude/3b43456e-f09e-5adb-b78c-d3b2ad830e83/scratchpad/build/uml2/sequenz-03-reservierung.png">    </p:cNvPr>
           <p:cNvPicPr>
             <a:picLocks noChangeAspect="1"/>
           </p:cNvPicPr>
@@ -12057,7 +12057,7 @@
       </p:sp>
       <p:pic>
         <p:nvPicPr>
-          <p:cNvPr id="7" name="Image 0" descr="/tmp/repo/tools/uml2/systemkontext.png">    </p:cNvPr>
+          <p:cNvPr id="7" name="Image 0" descr="/tmp/claude-0/-home-claude/3b43456e-f09e-5adb-b78c-d3b2ad830e83/scratchpad/build/uml2/systemkontext.png">    </p:cNvPr>
           <p:cNvPicPr>
             <a:picLocks noChangeAspect="1"/>
           </p:cNvPicPr>
@@ -12919,7 +12919,7 @@
       </p:sp>
       <p:pic>
         <p:nvPicPr>
-          <p:cNvPr id="6" name="Image 0" descr="/tmp/repo/tools/uml2/zustand-reparaturauftrag.png">    </p:cNvPr>
+          <p:cNvPr id="6" name="Image 0" descr="/tmp/claude-0/-home-claude/3b43456e-f09e-5adb-b78c-d3b2ad830e83/scratchpad/build/uml2/zustand-reparaturauftrag.png">    </p:cNvPr>
           <p:cNvPicPr>
             <a:picLocks noChangeAspect="1"/>
           </p:cNvPicPr>
@@ -16934,7 +16934,7 @@
                 <a:ea typeface="Calibri" pitchFamily="34" charset="-122"/>
                 <a:cs typeface="Calibri" pitchFamily="34" charset="-120"/>
               </a:rPr>
-              <a:t>Aktivitäten, im Schnitt 12,1 je Diagramm</a:t>
+              <a:t>Aktivitäten im Werkstatt-Pool, im Schnitt 12,1 je Diagramm</a:t>
             </a:r>
             <a:endParaRPr lang="en-US" sz="1100" dirty="0"/>
           </a:p>
@@ -17354,7 +17354,7 @@
                 <a:ea typeface="Calibri" pitchFamily="34" charset="-122"/>
                 <a:cs typeface="Calibri" pitchFamily="34" charset="-120"/>
               </a:rPr>
-              <a:t>Pool = Unternehmen: Werkstattbetrieb (Mandant), Kunde und Lieferant als Empty Pools. Lanes = Rollen: Service, Techniker, Werkstattleitung, Disposition.</a:t>
+              <a:t>Pool = Unternehmen: Werkstattbetrieb (Mandant), Kunde mit eigenem Ablauf, Lieferant als Black Box. Lanes = Rollen: Service, Techniker, Werkstattleitung, Disposition.</a:t>
             </a:r>
             <a:endParaRPr lang="en-US" sz="1150" dirty="0"/>
           </a:p>
@@ -17824,7 +17824,7 @@
       </p:sp>
       <p:pic>
         <p:nvPicPr>
-          <p:cNvPr id="26" name="Image 4" descr="/tmp/repo/tools/pres/crop-05-links.png">    </p:cNvPr>
+          <p:cNvPr id="26" name="Image 4" descr="/tmp/claude-0/-home-claude/3b43456e-f09e-5adb-b78c-d3b2ad830e83/scratchpad/build/pres/crop-05-links.png">    </p:cNvPr>
           <p:cNvPicPr>
             <a:picLocks noChangeAspect="1"/>
           </p:cNvPicPr>
@@ -18036,7 +18036,7 @@
       </p:sp>
       <p:pic>
         <p:nvPicPr>
-          <p:cNvPr id="6" name="Image 0" descr="/tmp/repo/tools/pres/crop-01-links.png">    </p:cNvPr>
+          <p:cNvPr id="6" name="Image 0" descr="/tmp/claude-0/-home-claude/3b43456e-f09e-5adb-b78c-d3b2ad830e83/scratchpad/build/pres/crop-01-links.png">    </p:cNvPr>
           <p:cNvPicPr>
             <a:picLocks noChangeAspect="1"/>
           </p:cNvPicPr>
@@ -18050,8 +18050,8 @@
         </p:blipFill>
         <p:spPr>
           <a:xfrm>
-            <a:off x="2533709" y="960120"/>
-            <a:ext cx="4076582" cy="2468880"/>
+            <a:off x="1579418" y="960120"/>
+            <a:ext cx="5985164" cy="2468880"/>
           </a:xfrm>
           <a:prstGeom prst="rect">
             <a:avLst/>
@@ -18091,7 +18091,7 @@
                 <a:ea typeface="Calibri" pitchFamily="34" charset="-122"/>
                 <a:cs typeface="Calibri" pitchFamily="34" charset="-120"/>
               </a:rPr>
-              <a:t>Linker Teil des Diagramms: Anfrage, Medienprüfung mit Rückfrage, KI-Diagnosevorschlag, Vorab-KVA, Verfügbarkeit</a:t>
+              <a:t>Ausschnitt Pool Kunde und Lane Service / Annahme: Aufnahme und Anfrage, Medienprüfung mit Rückfrage an den Kunden, KI-Diagnosevorschlag, Vorab-KVA</a:t>
             </a:r>
             <a:endParaRPr lang="en-US" sz="900" dirty="0"/>
           </a:p>
@@ -18134,7 +18134,7 @@
                 <a:ea typeface="Calibri" pitchFamily="34" charset="-122"/>
                 <a:cs typeface="Calibri" pitchFamily="34" charset="-120"/>
               </a:rPr>
-              <a:t>Auslöser: Nachricht aus der App mit Foto, Video oder Ton</a:t>
+              <a:t>Kunde: Foto, Video oder Ton aufnehmen und in der App senden; Auslöser für die Werkstatt ist diese Nachricht</a:t>
             </a:r>
             <a:endParaRPr lang="en-US" sz="1100" dirty="0"/>
           </a:p>

</xml_diff>

<commit_message>
[T04 2026-10-05] fix: refresh images, doku and slides after E-20
- PNGs P05/P06 (bpmn-js), SD3, SD6 und Use-Case-Diagramm (PlantUML) neu gerendert
- Folienausschnitt P05 neu, Bildmaße aktualisiert
- Projektdokumentation und Präsentation mit Kennzahlen nach E-20 (131 Aktivitäten, Ø 13,1)
- Entscheidungslog: Ø 13,1, offene Punkte zu E-20 präzisiert; Protokoll: E-20 bei Adrians Aufgabe
- README: erledigte Export-Aufgabe entfernt

Co-Authored-By: Claude Opus 5.5 <noreply@anthropic.com>
Claude-Session: https://claude.ai/code/session_01H2bGsFaySUqsEjJ1PXuxUw
</commit_message>
<xml_diff>
--- a/praesi/Abschlusspraesentation.pptx
+++ b/praesi/Abschlusspraesentation.pptx
@@ -4554,8 +4554,8 @@
         </p:blipFill>
         <p:spPr>
           <a:xfrm>
-            <a:off x="1220020" y="960120"/>
-            <a:ext cx="3412120" cy="3749040"/>
+            <a:off x="589722" y="960120"/>
+            <a:ext cx="4672717" cy="3749040"/>
           </a:xfrm>
           <a:prstGeom prst="rect">
             <a:avLst/>
@@ -5493,8 +5493,8 @@
         </p:blipFill>
         <p:spPr>
           <a:xfrm>
-            <a:off x="1501631" y="960120"/>
-            <a:ext cx="3580418" cy="3749040"/>
+            <a:off x="1420193" y="960120"/>
+            <a:ext cx="3743294" cy="3749040"/>
           </a:xfrm>
           <a:prstGeom prst="rect">
             <a:avLst/>
@@ -5601,7 +5601,7 @@
                 <a:ea typeface="Calibri" pitchFamily="34" charset="-122"/>
                 <a:cs typeface="Calibri" pitchFamily="34" charset="-120"/>
               </a:rPr>
-              <a:t>Kunde über Reparaturbeginn informieren; erst danach Bestellung bei Bedarf (UC10)</a:t>
+              <a:t>Kunde über Reparaturbeginn informieren; danach Bestellung nur bei Fehlteilen (UC10)</a:t>
             </a:r>
             <a:endParaRPr lang="en-US" sz="1050" dirty="0"/>
           </a:p>
@@ -7588,7 +7588,7 @@
                 <a:ea typeface="Calibri" pitchFamily="34" charset="-122"/>
                 <a:cs typeface="Calibri" pitchFamily="34" charset="-120"/>
               </a:rPr>
-              <a:t>BPMN-Kollaborationsdiagramme, 130 Aktivitäten</a:t>
+              <a:t>BPMN-Kollaborationsdiagramme, 131 Aktivitäten</a:t>
             </a:r>
             <a:endParaRPr lang="en-US" sz="1100" dirty="0"/>
           </a:p>
@@ -15109,7 +15109,7 @@
                           <a:ea typeface="Calibri" pitchFamily="34" charset="-122"/>
                           <a:cs typeface="Calibri" pitchFamily="34" charset="-120"/>
                         </a:rPr>
-                        <a:t>13</a:t>
+                        <a:t>14</a:t>
                       </a:r>
                       <a:endParaRPr lang="en-US" sz="950" dirty="0">
                         <a:latin typeface="Calibri" charset="0"/>
@@ -15174,7 +15174,7 @@
                           <a:ea typeface="Calibri" pitchFamily="34" charset="-122"/>
                           <a:cs typeface="Calibri" pitchFamily="34" charset="-120"/>
                         </a:rPr>
-                        <a:t>77 %</a:t>
+                        <a:t>79 %</a:t>
                       </a:r>
                       <a:endParaRPr lang="en-US" sz="950" dirty="0">
                         <a:latin typeface="Calibri" charset="0"/>
@@ -15501,7 +15501,7 @@
                           <a:ea typeface="Calibri" pitchFamily="34" charset="-122"/>
                           <a:cs typeface="Calibri" pitchFamily="34" charset="-120"/>
                         </a:rPr>
-                        <a:t>64 %</a:t>
+                        <a:t>57 %</a:t>
                       </a:r>
                       <a:endParaRPr lang="en-US" sz="950" dirty="0">
                         <a:latin typeface="Calibri" charset="0"/>
@@ -16895,7 +16895,7 @@
                 <a:ea typeface="Calibri" pitchFamily="34" charset="-122"/>
                 <a:cs typeface="Calibri" pitchFamily="34" charset="-120"/>
               </a:rPr>
-              <a:t>130</a:t>
+              <a:t>131</a:t>
             </a:r>
             <a:endParaRPr lang="en-US" sz="4000" dirty="0"/>
           </a:p>
@@ -16934,7 +16934,7 @@
                 <a:ea typeface="Calibri" pitchFamily="34" charset="-122"/>
                 <a:cs typeface="Calibri" pitchFamily="34" charset="-120"/>
               </a:rPr>
-              <a:t>Aktivitäten im Werkstatt-Pool, im Schnitt 13,0 je Diagramm</a:t>
+              <a:t>Aktivitäten im Werkstatt-Pool, im Schnitt 13,1 je Diagramm</a:t>
             </a:r>
             <a:endParaRPr lang="en-US" sz="1100" dirty="0"/>
           </a:p>
@@ -16973,7 +16973,7 @@
                 <a:ea typeface="Calibri" pitchFamily="34" charset="-122"/>
                 <a:cs typeface="Calibri" pitchFamily="34" charset="-120"/>
               </a:rPr>
-              <a:t>61 %</a:t>
+              <a:t>60 %</a:t>
             </a:r>
             <a:endParaRPr lang="en-US" sz="4000" dirty="0"/>
           </a:p>

</xml_diff>

<commit_message>
[T04 2026-10-05] fix: close QA findings Q1-Q3/B12 and finalize documents (E-22)
- P06: stop after second unanswered delivery reminder (cancel, alternative supplier)
- P10: receive replacement delivery before booking it
- SD4: parts disposition via UC09 for approved supplement, abort after second rework
- Doku: placeholders filled, status passages, images, TOC; slides aligned with doku
- abgabe/ABGABE-STATUS.md and KI-Angabe-Moodle.md (draft)

Co-Authored-By: Claude Opus 5.5 <noreply@anthropic.com>
Claude-Session: https://claude.ai/code/session_01H2bGsFaySUqsEjJ1PXuxUw
</commit_message>
<xml_diff>
--- a/praesi/Abschlusspraesentation.pptx
+++ b/praesi/Abschlusspraesentation.pptx
@@ -1143,7 +1143,8 @@
           <a:p>
             <a:r>
               <a:rPr lang="en-US" dirty="0"/>
-              <a:t>Vortragende(r): David</a:t>
+              <a:t>Vortragende(r): David
+Scrum im Takt der Gruppentermine: Review, Retrospektive und Planning je Termin. Jede Änderung über Branch, Pull Request und Review; Merge durch Jakob als Qualitätsmanager. Abstimmung über WhatsApp, Dateien nur über GitHub.</a:t>
             </a:r>
             <a:endParaRPr lang="en-US" dirty="0"/>
           </a:p>
@@ -1231,7 +1232,8 @@
           <a:p>
             <a:r>
               <a:rPr lang="en-US" dirty="0"/>
-              <a:t>Vortragende(r): Jakob</a:t>
+              <a:t>Vortragende(r): Jakob
+Beispiel für die Konsistenzprüfung: Nach den Korrekturen an Prozess 07 (E-19) musste SD4 nachgezogen werden. Prüfrunden: Gesamtprüfung am 26.09., Komplettcheck am 05.10. mit 26 Befunden, QA-Checkliste mit Q1 bis Q8.</a:t>
             </a:r>
             <a:endParaRPr lang="en-US" dirty="0"/>
           </a:p>
@@ -1319,7 +1321,8 @@
           <a:p>
             <a:r>
               <a:rPr lang="en-US" dirty="0"/>
-              <a:t>Vortragende(r): Nina</a:t>
+              <a:t>Vortragende(r): Nina
+Kennzahlen kurz nennen, dann die zwei Kernaussagen. Der Ausblick ist Vision, nicht modelliert.</a:t>
             </a:r>
             <a:endParaRPr lang="en-US" dirty="0"/>
           </a:p>
@@ -1495,7 +1498,8 @@
           <a:p>
             <a:r>
               <a:rPr lang="en-US" dirty="0"/>
-              <a:t>Vortragende(r): Nina</a:t>
+              <a:t>Vortragende(r): Nina
+Kurz die sieben Teile und die Vortragenden nennen; Fragen bitte am Ende.</a:t>
             </a:r>
             <a:endParaRPr lang="en-US" dirty="0"/>
           </a:p>
@@ -1673,7 +1677,7 @@
             <a:r>
               <a:rPr lang="en-US" dirty="0"/>
               <a:t>Vortragende(r): David
-Pilotkunde FixWerk GmbH: vier Filialen, Fahrrad, E-Bike und Elektronik.</a:t>
+FixWerk GmbH ist ein fiktiver Pilotkunde mit vier Filialen in der Region Karlsruhe (Fahrrad, E-Bike, Elektronik). Die vier Probleme sind Annahmen unseres Szenarios, keine erhobenen Daten.</a:t>
             </a:r>
             <a:endParaRPr lang="en-US" dirty="0"/>
           </a:p>
@@ -1761,7 +1765,8 @@
           <a:p>
             <a:r>
               <a:rPr lang="en-US" dirty="0"/>
-              <a:t>Vortragende(r): Adrian</a:t>
+              <a:t>Vortragende(r): Adrian
+Rückfrage des Dozenten bei der Konzeptvorstellung: Betreiber oder Solution Provider? Wir sind der Softwareanbieter, FixWerk ist der Pilotkunde. Systemkontext: Buchhaltung, Lieferantensysteme und die physische Reparatur liegen außerhalb der Systemgrenze.</a:t>
             </a:r>
             <a:endParaRPr lang="en-US" dirty="0"/>
           </a:p>
@@ -1850,7 +1855,7 @@
             <a:r>
               <a:rPr lang="en-US" dirty="0"/>
               <a:t>Vortragende(r): Adrian
-Fahrrad: fixdesk, RO App, Repero. Elektronik: RepairDesk, RepairShopr. Stand der Recherche September 2026.</a:t>
+Die drei Merkmale beschreiben den Zuschnitt unseres Entwurfs. Einen belegten Funktionsvergleich mit bestehenden Werkstattlösungen haben wir nicht erstellt; deshalb nennen wir keine Wettbewerber.</a:t>
             </a:r>
             <a:endParaRPr lang="en-US" dirty="0"/>
           </a:p>
@@ -2027,7 +2032,8 @@
           <a:p>
             <a:r>
               <a:rPr lang="en-US" dirty="0"/>
-              <a:t>Vortragende(r): Maximilian</a:t>
+              <a:t>Vortragende(r): Maximilian
+Prozesse 01 bis 08 sind die Auftragsreise entlang des Zustandsautomaten, 09 und 10 die Folgeprozesse Reklamation und Retoure. Gezählt sind nur die Aktivitäten im Werkstatt-Pool; die 26 Aktivitäten der Kundenabläufe kommen hinzu.</a:t>
             </a:r>
             <a:endParaRPr lang="en-US" dirty="0"/>
           </a:p>
@@ -4554,8 +4560,8 @@
         </p:blipFill>
         <p:spPr>
           <a:xfrm>
-            <a:off x="589722" y="960120"/>
-            <a:ext cx="4672717" cy="3749040"/>
+            <a:off x="1212172" y="960120"/>
+            <a:ext cx="3427817" cy="3749040"/>
           </a:xfrm>
           <a:prstGeom prst="rect">
             <a:avLst/>
@@ -7053,7 +7059,7 @@
                 <a:ea typeface="Calibri" pitchFamily="34" charset="-122"/>
                 <a:cs typeface="Calibri" pitchFamily="34" charset="-120"/>
               </a:rPr>
-              <a:t>Datenobjekte, Klassen, Lebenslinien und Statuswerte müssen wortgleich sein. Eine gemeinsame Modellbeschreibung als Single Source of Truth hat die Abweichungen beseitigt.</a:t>
+              <a:t>Datenobjekte, Klassen, Lebenslinien und Statuswerte müssen wortgleich sein. Gemeinsame Namensregeln und ein Abgleich nach jeder Änderung (QA-Checkliste) halten die Modelle zusammen.</a:t>
             </a:r>
             <a:endParaRPr lang="en-US" sz="1150" dirty="0"/>
           </a:p>
@@ -11157,7 +11163,7 @@
                 <a:ea typeface="Calibri" pitchFamily="34" charset="-122"/>
                 <a:cs typeface="Calibri" pitchFamily="34" charset="-120"/>
               </a:rPr>
-              <a:t>Unabhängige Reparaturwerkstätten für Fahrräder, E-Bikes und Elektronik wachsen, ihre Abläufe nicht. Unser Pilotkunde FixWerk GmbH (vier Filialen) zeigt die typischen Probleme:</a:t>
+              <a:t>Unser Szenario: Die fiktive Werkstattkette FixWerk GmbH (vier Filialen, Fahrrad, E-Bike und Elektronik) arbeitet mit Papier, Excel-Listen und Telefon. Wir gehen von vier Problemen aus:</a:t>
             </a:r>
             <a:endParaRPr lang="en-US" sz="1300" dirty="0"/>
           </a:p>
@@ -12183,7 +12189,7 @@
                 <a:ea typeface="Calibri" pitchFamily="34" charset="-122"/>
                 <a:cs typeface="Calibri" pitchFamily="34" charset="-120"/>
               </a:rPr>
-              <a:t>Markt und Wettbewerb: drei Unterschiede</a:t>
+              <a:t>Unser Zuschnitt: drei Merkmale</a:t>
             </a:r>
             <a:endParaRPr lang="en-US" sz="2800" dirty="0"/>
           </a:p>
@@ -12300,7 +12306,7 @@
                 <a:ea typeface="Calibri" pitchFamily="34" charset="-122"/>
                 <a:cs typeface="Calibri" pitchFamily="34" charset="-120"/>
               </a:rPr>
-              <a:t>Werkstattsoftware gibt es, aber getrennt nach Welten: Fahrrad (fixdesk, RO App, Repero) oder Elektronik (RepairDesk, RepairShopr).</a:t>
+              <a:t>RepairFlow soll Fahrrad-, E-Bike- und Elektronikreparaturen gemeinsam abbilden. Drei Merkmale prägen unseren Entwurf:</a:t>
             </a:r>
             <a:endParaRPr lang="en-US" sz="1300" dirty="0"/>
           </a:p>

</xml_diff>